<commit_message>
Polish final CS13 submission and update README after merge
</commit_message>
<xml_diff>
--- a/Tennhombimat_CS13_Slide.pptx
+++ b/Tennhombimat_CS13_Slide.pptx
@@ -2,13 +2,13 @@
 <file path=ppt/presentation.xml><?xml version="1.0" encoding="utf-8"?>
 <p:presentation xmlns:p="http://schemas.openxmlformats.org/presentationml/2006/main">
   <p:sldMasterIdLst>
-    <p:sldMasterId xmlns:r="http://schemas.openxmlformats.org/officeDocument/2006/relationships" id="2147483648" r:id="R88f79532ffd34fbd"/>
+    <p:sldMasterId xmlns:r="http://schemas.openxmlformats.org/officeDocument/2006/relationships" id="2147483648" r:id="Rd55a9432f84347e9"/>
   </p:sldMasterIdLst>
   <p:notesMasterIdLst>
-    <p:notesMasterId xmlns:r="http://schemas.openxmlformats.org/officeDocument/2006/relationships" r:id="Rb7c7fe0b42a04048"/>
+    <p:notesMasterId xmlns:r="http://schemas.openxmlformats.org/officeDocument/2006/relationships" r:id="Rd63c14e65523456a"/>
   </p:notesMasterIdLst>
   <p:sldIdLst>
-    <p:sldId xmlns:r="http://schemas.openxmlformats.org/officeDocument/2006/relationships" id="256" r:id="R34ed2bcd921f4cbb"/>
+    <p:sldId xmlns:r="http://schemas.openxmlformats.org/officeDocument/2006/relationships" id="256" r:id="Rd6b93e0ab8a54a1a"/>
   </p:sldIdLst>
   <p:sldSz cx="15240000" cy="8572500"/>
   <p:notesSz cx="6858000" cy="9144000"/>
@@ -442,7 +442,7 @@
           <a:lstStyle xmlns:a="http://schemas.openxmlformats.org/drawingml/2006/main"/>
           <a:p xmlns:a="http://schemas.openxmlformats.org/drawingml/2006/main">
             <a:r>
-              <a:t>Nguồn: CS13_HoSoTinhHuong.pdf trang 6–7, CHECKPOINTS.md CP1–CP5 và RaVien_CS13.xlsx trang 1–5. Dữ liệu là giả định học tập. Kết quả hiện có: 40 ca, 96,6%, 1 lỗi nghiêm trọng, 0 tầng tụt, kappa 0,90; CHƯA phát hành. Cổng Mức 1: sửa insulin, thêm 5 ca, chạy cả 45 ca, 0 lỗi nghiêm trọng, đạt quy thực tế &gt;=95%, kappa &gt;=0,8, 0 tầng tụt. Mức 2 là đề xuất sau 600 bản được DS kiểm 100%, 0 lỗi thuốc nghiêm trọng và các cổng hiệu quả. BS luôn ký 100%; 10% chỉ là tổng tỷ lệ DS mục tiêu có điều kiện. Không giới hạn cờ để làm đẹp biên. 3/600 xấp xỉ 0,5% là giới hạn gần đúng, không bảo đảm an toàn. Giờ chuyên gia mỗi tuần và ngày khởi động chưa có. Biên 6,656% và 60,656% dùng giá 15 triệu, 1.200 bản; chưa bao gồm chi phí cố định. Mức 3 không làm.</a:t>
+              <a:t>Nguồn: docs/CS13_HoSoTinhHuong.pdf, trang 6–7; CHECKPOINTS.md CP1–CP5; Tennhombimat_CS13.xlsx, trang 1–5. Số liệu giả định của bài lab. Bản hiện tại chưa phát hành: bộ 40 ca đạt 96,6%, có 1 lỗi nghiêm trọng, 0 tầng tụt, kappa 0,90. Cổng Mức 1: sửa insulin, thêm 5 ca, chạy lại 45 ca với 0 lỗi nghiêm trọng, tỷ lệ đạt quy về thực tế &gt;=95%, kappa &gt;=0,8, 0 tầng tụt. Cổng Mức 2 là đề xuất: 600 bản liên tiếp được DS kiểm 100% và 0 lỗi thuốc nghiêm trọng, giữ cổng hồi quy, đạt chỉ số hiệu quả tháng pilot thứ ba. BS luôn ký 100%. Tổng DS 10% có điều kiện, gồm mọi cờ/rủi ro và mẫu ngẫu nhiên; không giới hạn cờ để đạt biên. Quy tắc 3/600 xấp xỉ 0,5% không bảo đảm tỷ lệ lỗi thực bằng 0. Dự toán bổ sung: BS chấm đánh giá 2 giờ/tuần, DS 4 giờ/tuần, 45 ca dự trù 24,3 giờ tổng; lịch thực tế cần xác nhận. DS 4 giờ/tuần kiểm tối đa 80 bản/tuần, ít nhất 8 tuần cho 600 bản. Kinh tế đủ 1.200 bản/tháng đòi 60 giờ DS ở Mức 1 hoặc 6 giờ ở Mức 2 nếu tổng duyệt 10%. Biên 6,656% và 60,656% chưa trừ chi phí cố định. Mức 3 không triển khai.</a:t>
             </a:r>
           </a:p>
         </p:txBody>
@@ -540,6 +540,7 @@
                 <a:spcPts val="0"/>
               </a:spcAft>
               <a:buNone/>
+              <a:defRPr/>
             </a:lvl1pPr>
             <a:lvl2pPr marL="0" indent="0">
               <a:lnSpc>
@@ -552,6 +553,7 @@
                 <a:spcPts val="0"/>
               </a:spcAft>
               <a:buNone/>
+              <a:defRPr/>
             </a:lvl2pPr>
             <a:lvl3pPr marL="0" indent="0">
               <a:lnSpc>
@@ -564,6 +566,7 @@
                 <a:spcPts val="0"/>
               </a:spcAft>
               <a:buNone/>
+              <a:defRPr/>
             </a:lvl3pPr>
             <a:lvl4pPr marL="0" indent="0">
               <a:lnSpc>
@@ -576,6 +579,7 @@
                 <a:spcPts val="0"/>
               </a:spcAft>
               <a:buNone/>
+              <a:defRPr/>
             </a:lvl4pPr>
             <a:lvl5pPr marL="0" indent="0">
               <a:lnSpc>
@@ -588,6 +592,7 @@
                 <a:spcPts val="0"/>
               </a:spcAft>
               <a:buNone/>
+              <a:defRPr/>
             </a:lvl5pPr>
             <a:lvl6pPr marL="0" indent="0">
               <a:lnSpc>
@@ -600,6 +605,7 @@
                 <a:spcPts val="0"/>
               </a:spcAft>
               <a:buNone/>
+              <a:defRPr/>
             </a:lvl6pPr>
             <a:lvl7pPr marL="0" indent="0">
               <a:lnSpc>
@@ -612,6 +618,7 @@
                 <a:spcPts val="0"/>
               </a:spcAft>
               <a:buNone/>
+              <a:defRPr/>
             </a:lvl7pPr>
             <a:lvl8pPr marL="0" indent="0">
               <a:lnSpc>
@@ -624,6 +631,7 @@
                 <a:spcPts val="0"/>
               </a:spcAft>
               <a:buNone/>
+              <a:defRPr/>
             </a:lvl8pPr>
             <a:lvl9pPr marL="0" indent="0">
               <a:lnSpc>
@@ -636,6 +644,7 @@
                 <a:spcPts val="0"/>
               </a:spcAft>
               <a:buNone/>
+              <a:defRPr/>
             </a:lvl9pPr>
           </a:lstStyle>
           <a:p xmlns:a="http://schemas.openxmlformats.org/drawingml/2006/main"/>
@@ -697,6 +706,7 @@
                 <a:spcPts val="0"/>
               </a:spcAft>
               <a:buNone/>
+              <a:defRPr/>
             </a:lvl1pPr>
             <a:lvl2pPr marL="0" indent="0">
               <a:lnSpc>
@@ -709,6 +719,7 @@
                 <a:spcPts val="0"/>
               </a:spcAft>
               <a:buNone/>
+              <a:defRPr/>
             </a:lvl2pPr>
             <a:lvl3pPr marL="0" indent="0">
               <a:lnSpc>
@@ -721,6 +732,7 @@
                 <a:spcPts val="0"/>
               </a:spcAft>
               <a:buNone/>
+              <a:defRPr/>
             </a:lvl3pPr>
             <a:lvl4pPr marL="0" indent="0">
               <a:lnSpc>
@@ -733,6 +745,7 @@
                 <a:spcPts val="0"/>
               </a:spcAft>
               <a:buNone/>
+              <a:defRPr/>
             </a:lvl4pPr>
             <a:lvl5pPr marL="0" indent="0">
               <a:lnSpc>
@@ -745,6 +758,7 @@
                 <a:spcPts val="0"/>
               </a:spcAft>
               <a:buNone/>
+              <a:defRPr/>
             </a:lvl5pPr>
             <a:lvl6pPr marL="0" indent="0">
               <a:lnSpc>
@@ -757,6 +771,7 @@
                 <a:spcPts val="0"/>
               </a:spcAft>
               <a:buNone/>
+              <a:defRPr/>
             </a:lvl6pPr>
             <a:lvl7pPr marL="0" indent="0">
               <a:lnSpc>
@@ -769,6 +784,7 @@
                 <a:spcPts val="0"/>
               </a:spcAft>
               <a:buNone/>
+              <a:defRPr/>
             </a:lvl7pPr>
             <a:lvl8pPr marL="0" indent="0">
               <a:lnSpc>
@@ -781,6 +797,7 @@
                 <a:spcPts val="0"/>
               </a:spcAft>
               <a:buNone/>
+              <a:defRPr/>
             </a:lvl8pPr>
             <a:lvl9pPr marL="0" indent="0">
               <a:lnSpc>
@@ -793,6 +810,7 @@
                 <a:spcPts val="0"/>
               </a:spcAft>
               <a:buNone/>
+              <a:defRPr/>
             </a:lvl9pPr>
           </a:lstStyle>
           <a:p xmlns:a="http://schemas.openxmlformats.org/drawingml/2006/main"/>
@@ -871,6 +889,7 @@
                 <a:spcPts val="0"/>
               </a:spcAft>
               <a:buNone/>
+              <a:defRPr/>
             </a:lvl1pPr>
             <a:lvl2pPr marL="0" indent="0">
               <a:lnSpc>
@@ -883,6 +902,7 @@
                 <a:spcPts val="0"/>
               </a:spcAft>
               <a:buNone/>
+              <a:defRPr/>
             </a:lvl2pPr>
             <a:lvl3pPr marL="0" indent="0">
               <a:lnSpc>
@@ -895,6 +915,7 @@
                 <a:spcPts val="0"/>
               </a:spcAft>
               <a:buNone/>
+              <a:defRPr/>
             </a:lvl3pPr>
             <a:lvl4pPr marL="0" indent="0">
               <a:lnSpc>
@@ -907,6 +928,7 @@
                 <a:spcPts val="0"/>
               </a:spcAft>
               <a:buNone/>
+              <a:defRPr/>
             </a:lvl4pPr>
             <a:lvl5pPr marL="0" indent="0">
               <a:lnSpc>
@@ -919,6 +941,7 @@
                 <a:spcPts val="0"/>
               </a:spcAft>
               <a:buNone/>
+              <a:defRPr/>
             </a:lvl5pPr>
             <a:lvl6pPr marL="0" indent="0">
               <a:lnSpc>
@@ -931,6 +954,7 @@
                 <a:spcPts val="0"/>
               </a:spcAft>
               <a:buNone/>
+              <a:defRPr/>
             </a:lvl6pPr>
             <a:lvl7pPr marL="0" indent="0">
               <a:lnSpc>
@@ -943,6 +967,7 @@
                 <a:spcPts val="0"/>
               </a:spcAft>
               <a:buNone/>
+              <a:defRPr/>
             </a:lvl7pPr>
             <a:lvl8pPr marL="0" indent="0">
               <a:lnSpc>
@@ -955,6 +980,7 @@
                 <a:spcPts val="0"/>
               </a:spcAft>
               <a:buNone/>
+              <a:defRPr/>
             </a:lvl8pPr>
             <a:lvl9pPr marL="0" indent="0">
               <a:lnSpc>
@@ -967,6 +993,7 @@
                 <a:spcPts val="0"/>
               </a:spcAft>
               <a:buNone/>
+              <a:defRPr/>
             </a:lvl9pPr>
           </a:lstStyle>
           <a:p xmlns:a="http://schemas.openxmlformats.org/drawingml/2006/main"/>
@@ -1045,6 +1072,7 @@
                 <a:spcPts val="0"/>
               </a:spcAft>
               <a:buNone/>
+              <a:defRPr/>
             </a:lvl1pPr>
             <a:lvl2pPr marL="0" indent="0">
               <a:lnSpc>
@@ -1057,6 +1085,7 @@
                 <a:spcPts val="0"/>
               </a:spcAft>
               <a:buNone/>
+              <a:defRPr/>
             </a:lvl2pPr>
             <a:lvl3pPr marL="0" indent="0">
               <a:lnSpc>
@@ -1069,6 +1098,7 @@
                 <a:spcPts val="0"/>
               </a:spcAft>
               <a:buNone/>
+              <a:defRPr/>
             </a:lvl3pPr>
             <a:lvl4pPr marL="0" indent="0">
               <a:lnSpc>
@@ -1081,6 +1111,7 @@
                 <a:spcPts val="0"/>
               </a:spcAft>
               <a:buNone/>
+              <a:defRPr/>
             </a:lvl4pPr>
             <a:lvl5pPr marL="0" indent="0">
               <a:lnSpc>
@@ -1093,6 +1124,7 @@
                 <a:spcPts val="0"/>
               </a:spcAft>
               <a:buNone/>
+              <a:defRPr/>
             </a:lvl5pPr>
             <a:lvl6pPr marL="0" indent="0">
               <a:lnSpc>
@@ -1105,6 +1137,7 @@
                 <a:spcPts val="0"/>
               </a:spcAft>
               <a:buNone/>
+              <a:defRPr/>
             </a:lvl6pPr>
             <a:lvl7pPr marL="0" indent="0">
               <a:lnSpc>
@@ -1117,6 +1150,7 @@
                 <a:spcPts val="0"/>
               </a:spcAft>
               <a:buNone/>
+              <a:defRPr/>
             </a:lvl7pPr>
             <a:lvl8pPr marL="0" indent="0">
               <a:lnSpc>
@@ -1129,6 +1163,7 @@
                 <a:spcPts val="0"/>
               </a:spcAft>
               <a:buNone/>
+              <a:defRPr/>
             </a:lvl8pPr>
             <a:lvl9pPr marL="0" indent="0">
               <a:lnSpc>
@@ -1141,6 +1176,7 @@
                 <a:spcPts val="0"/>
               </a:spcAft>
               <a:buNone/>
+              <a:defRPr/>
             </a:lvl9pPr>
           </a:lstStyle>
           <a:p xmlns:a="http://schemas.openxmlformats.org/drawingml/2006/main"/>
@@ -1202,6 +1238,7 @@
                 <a:spcPts val="1500"/>
               </a:spcAft>
               <a:buChar char="•"/>
+              <a:defRPr/>
             </a:lvl1pPr>
             <a:lvl2pPr marL="666750" indent="-285750">
               <a:lnSpc>
@@ -1214,6 +1251,7 @@
                 <a:spcPts val="1500"/>
               </a:spcAft>
               <a:buChar char="•"/>
+              <a:defRPr/>
             </a:lvl2pPr>
             <a:lvl3pPr marL="1047750" indent="-285750">
               <a:lnSpc>
@@ -1226,6 +1264,7 @@
                 <a:spcPts val="1500"/>
               </a:spcAft>
               <a:buChar char="•"/>
+              <a:defRPr/>
             </a:lvl3pPr>
             <a:lvl4pPr marL="1428750" indent="-285750">
               <a:lnSpc>
@@ -1238,6 +1277,7 @@
                 <a:spcPts val="1500"/>
               </a:spcAft>
               <a:buChar char="•"/>
+              <a:defRPr/>
             </a:lvl4pPr>
             <a:lvl5pPr marL="1809750" indent="-285750">
               <a:lnSpc>
@@ -1250,6 +1290,7 @@
                 <a:spcPts val="1500"/>
               </a:spcAft>
               <a:buChar char="•"/>
+              <a:defRPr/>
             </a:lvl5pPr>
             <a:lvl6pPr marL="2190750" indent="-285750">
               <a:lnSpc>
@@ -1262,6 +1303,7 @@
                 <a:spcPts val="1500"/>
               </a:spcAft>
               <a:buChar char="•"/>
+              <a:defRPr/>
             </a:lvl6pPr>
             <a:lvl7pPr marL="2571750" indent="-285750">
               <a:lnSpc>
@@ -1274,6 +1316,7 @@
                 <a:spcPts val="1500"/>
               </a:spcAft>
               <a:buChar char="•"/>
+              <a:defRPr/>
             </a:lvl7pPr>
             <a:lvl8pPr marL="2952750" indent="-285750">
               <a:lnSpc>
@@ -1286,6 +1329,7 @@
                 <a:spcPts val="1500"/>
               </a:spcAft>
               <a:buChar char="•"/>
+              <a:defRPr/>
             </a:lvl8pPr>
             <a:lvl9pPr marL="3333750" indent="-285750">
               <a:lnSpc>
@@ -1298,6 +1342,7 @@
                 <a:spcPts val="1500"/>
               </a:spcAft>
               <a:buChar char="•"/>
+              <a:defRPr/>
             </a:lvl9pPr>
           </a:lstStyle>
           <a:p xmlns:a="http://schemas.openxmlformats.org/drawingml/2006/main"/>
@@ -1376,6 +1421,7 @@
                 <a:spcPts val="0"/>
               </a:spcAft>
               <a:buNone/>
+              <a:defRPr/>
             </a:lvl1pPr>
             <a:lvl2pPr marL="0" indent="0">
               <a:lnSpc>
@@ -1388,6 +1434,7 @@
                 <a:spcPts val="0"/>
               </a:spcAft>
               <a:buNone/>
+              <a:defRPr/>
             </a:lvl2pPr>
             <a:lvl3pPr marL="0" indent="0">
               <a:lnSpc>
@@ -1400,6 +1447,7 @@
                 <a:spcPts val="0"/>
               </a:spcAft>
               <a:buNone/>
+              <a:defRPr/>
             </a:lvl3pPr>
             <a:lvl4pPr marL="0" indent="0">
               <a:lnSpc>
@@ -1412,6 +1460,7 @@
                 <a:spcPts val="0"/>
               </a:spcAft>
               <a:buNone/>
+              <a:defRPr/>
             </a:lvl4pPr>
             <a:lvl5pPr marL="0" indent="0">
               <a:lnSpc>
@@ -1424,6 +1473,7 @@
                 <a:spcPts val="0"/>
               </a:spcAft>
               <a:buNone/>
+              <a:defRPr/>
             </a:lvl5pPr>
             <a:lvl6pPr marL="0" indent="0">
               <a:lnSpc>
@@ -1436,6 +1486,7 @@
                 <a:spcPts val="0"/>
               </a:spcAft>
               <a:buNone/>
+              <a:defRPr/>
             </a:lvl6pPr>
             <a:lvl7pPr marL="0" indent="0">
               <a:lnSpc>
@@ -1448,6 +1499,7 @@
                 <a:spcPts val="0"/>
               </a:spcAft>
               <a:buNone/>
+              <a:defRPr/>
             </a:lvl7pPr>
             <a:lvl8pPr marL="0" indent="0">
               <a:lnSpc>
@@ -1460,6 +1512,7 @@
                 <a:spcPts val="0"/>
               </a:spcAft>
               <a:buNone/>
+              <a:defRPr/>
             </a:lvl8pPr>
             <a:lvl9pPr marL="0" indent="0">
               <a:lnSpc>
@@ -1472,6 +1525,7 @@
                 <a:spcPts val="0"/>
               </a:spcAft>
               <a:buNone/>
+              <a:defRPr/>
             </a:lvl9pPr>
           </a:lstStyle>
           <a:p xmlns:a="http://schemas.openxmlformats.org/drawingml/2006/main"/>
@@ -1533,6 +1587,7 @@
                 <a:spcPts val="1500"/>
               </a:spcAft>
               <a:buChar char="•"/>
+              <a:defRPr/>
             </a:lvl1pPr>
             <a:lvl2pPr marL="666750" indent="-285750">
               <a:lnSpc>
@@ -1545,6 +1600,7 @@
                 <a:spcPts val="1500"/>
               </a:spcAft>
               <a:buChar char="•"/>
+              <a:defRPr/>
             </a:lvl2pPr>
             <a:lvl3pPr marL="1047750" indent="-285750">
               <a:lnSpc>
@@ -1557,6 +1613,7 @@
                 <a:spcPts val="1500"/>
               </a:spcAft>
               <a:buChar char="•"/>
+              <a:defRPr/>
             </a:lvl3pPr>
             <a:lvl4pPr marL="1428750" indent="-285750">
               <a:lnSpc>
@@ -1569,6 +1626,7 @@
                 <a:spcPts val="1500"/>
               </a:spcAft>
               <a:buChar char="•"/>
+              <a:defRPr/>
             </a:lvl4pPr>
             <a:lvl5pPr marL="1809750" indent="-285750">
               <a:lnSpc>
@@ -1581,6 +1639,7 @@
                 <a:spcPts val="1500"/>
               </a:spcAft>
               <a:buChar char="•"/>
+              <a:defRPr/>
             </a:lvl5pPr>
             <a:lvl6pPr marL="2190750" indent="-285750">
               <a:lnSpc>
@@ -1593,6 +1652,7 @@
                 <a:spcPts val="1500"/>
               </a:spcAft>
               <a:buChar char="•"/>
+              <a:defRPr/>
             </a:lvl6pPr>
             <a:lvl7pPr marL="2571750" indent="-285750">
               <a:lnSpc>
@@ -1605,6 +1665,7 @@
                 <a:spcPts val="1500"/>
               </a:spcAft>
               <a:buChar char="•"/>
+              <a:defRPr/>
             </a:lvl7pPr>
             <a:lvl8pPr marL="2952750" indent="-285750">
               <a:lnSpc>
@@ -1617,6 +1678,7 @@
                 <a:spcPts val="1500"/>
               </a:spcAft>
               <a:buChar char="•"/>
+              <a:defRPr/>
             </a:lvl8pPr>
             <a:lvl9pPr marL="3333750" indent="-285750">
               <a:lnSpc>
@@ -1629,6 +1691,7 @@
                 <a:spcPts val="1500"/>
               </a:spcAft>
               <a:buChar char="•"/>
+              <a:defRPr/>
             </a:lvl9pPr>
           </a:lstStyle>
           <a:p xmlns:a="http://schemas.openxmlformats.org/drawingml/2006/main"/>
@@ -1690,6 +1753,7 @@
                 <a:spcPts val="1500"/>
               </a:spcAft>
               <a:buChar char="•"/>
+              <a:defRPr/>
             </a:lvl1pPr>
             <a:lvl2pPr marL="666750" indent="-285750">
               <a:lnSpc>
@@ -1702,6 +1766,7 @@
                 <a:spcPts val="1500"/>
               </a:spcAft>
               <a:buChar char="•"/>
+              <a:defRPr/>
             </a:lvl2pPr>
             <a:lvl3pPr marL="1047750" indent="-285750">
               <a:lnSpc>
@@ -1714,6 +1779,7 @@
                 <a:spcPts val="1500"/>
               </a:spcAft>
               <a:buChar char="•"/>
+              <a:defRPr/>
             </a:lvl3pPr>
             <a:lvl4pPr marL="1428750" indent="-285750">
               <a:lnSpc>
@@ -1726,6 +1792,7 @@
                 <a:spcPts val="1500"/>
               </a:spcAft>
               <a:buChar char="•"/>
+              <a:defRPr/>
             </a:lvl4pPr>
             <a:lvl5pPr marL="1809750" indent="-285750">
               <a:lnSpc>
@@ -1738,6 +1805,7 @@
                 <a:spcPts val="1500"/>
               </a:spcAft>
               <a:buChar char="•"/>
+              <a:defRPr/>
             </a:lvl5pPr>
             <a:lvl6pPr marL="2190750" indent="-285750">
               <a:lnSpc>
@@ -1750,6 +1818,7 @@
                 <a:spcPts val="1500"/>
               </a:spcAft>
               <a:buChar char="•"/>
+              <a:defRPr/>
             </a:lvl6pPr>
             <a:lvl7pPr marL="2571750" indent="-285750">
               <a:lnSpc>
@@ -1762,6 +1831,7 @@
                 <a:spcPts val="1500"/>
               </a:spcAft>
               <a:buChar char="•"/>
+              <a:defRPr/>
             </a:lvl7pPr>
             <a:lvl8pPr marL="2952750" indent="-285750">
               <a:lnSpc>
@@ -1774,6 +1844,7 @@
                 <a:spcPts val="1500"/>
               </a:spcAft>
               <a:buChar char="•"/>
+              <a:defRPr/>
             </a:lvl8pPr>
             <a:lvl9pPr marL="3333750" indent="-285750">
               <a:lnSpc>
@@ -1786,6 +1857,7 @@
                 <a:spcPts val="1500"/>
               </a:spcAft>
               <a:buChar char="•"/>
+              <a:defRPr/>
             </a:lvl9pPr>
           </a:lstStyle>
           <a:p xmlns:a="http://schemas.openxmlformats.org/drawingml/2006/main"/>
@@ -1864,6 +1936,7 @@
                 <a:spcPts val="0"/>
               </a:spcAft>
               <a:buNone/>
+              <a:defRPr/>
             </a:lvl1pPr>
             <a:lvl2pPr marL="0" indent="0">
               <a:lnSpc>
@@ -1876,6 +1949,7 @@
                 <a:spcPts val="0"/>
               </a:spcAft>
               <a:buNone/>
+              <a:defRPr/>
             </a:lvl2pPr>
             <a:lvl3pPr marL="0" indent="0">
               <a:lnSpc>
@@ -1888,6 +1962,7 @@
                 <a:spcPts val="0"/>
               </a:spcAft>
               <a:buNone/>
+              <a:defRPr/>
             </a:lvl3pPr>
             <a:lvl4pPr marL="0" indent="0">
               <a:lnSpc>
@@ -1900,6 +1975,7 @@
                 <a:spcPts val="0"/>
               </a:spcAft>
               <a:buNone/>
+              <a:defRPr/>
             </a:lvl4pPr>
             <a:lvl5pPr marL="0" indent="0">
               <a:lnSpc>
@@ -1912,6 +1988,7 @@
                 <a:spcPts val="0"/>
               </a:spcAft>
               <a:buNone/>
+              <a:defRPr/>
             </a:lvl5pPr>
             <a:lvl6pPr marL="0" indent="0">
               <a:lnSpc>
@@ -1924,6 +2001,7 @@
                 <a:spcPts val="0"/>
               </a:spcAft>
               <a:buNone/>
+              <a:defRPr/>
             </a:lvl6pPr>
             <a:lvl7pPr marL="0" indent="0">
               <a:lnSpc>
@@ -1936,6 +2014,7 @@
                 <a:spcPts val="0"/>
               </a:spcAft>
               <a:buNone/>
+              <a:defRPr/>
             </a:lvl7pPr>
             <a:lvl8pPr marL="0" indent="0">
               <a:lnSpc>
@@ -1948,6 +2027,7 @@
                 <a:spcPts val="0"/>
               </a:spcAft>
               <a:buNone/>
+              <a:defRPr/>
             </a:lvl8pPr>
             <a:lvl9pPr marL="0" indent="0">
               <a:lnSpc>
@@ -1960,6 +2040,7 @@
                 <a:spcPts val="0"/>
               </a:spcAft>
               <a:buNone/>
+              <a:defRPr/>
             </a:lvl9pPr>
           </a:lstStyle>
           <a:p xmlns:a="http://schemas.openxmlformats.org/drawingml/2006/main"/>
@@ -2021,6 +2102,7 @@
                 <a:spcPts val="1500"/>
               </a:spcAft>
               <a:buChar char="•"/>
+              <a:defRPr/>
             </a:lvl1pPr>
             <a:lvl2pPr marL="666750" indent="-285750">
               <a:lnSpc>
@@ -2033,6 +2115,7 @@
                 <a:spcPts val="1500"/>
               </a:spcAft>
               <a:buChar char="•"/>
+              <a:defRPr/>
             </a:lvl2pPr>
             <a:lvl3pPr marL="1047750" indent="-285750">
               <a:lnSpc>
@@ -2045,6 +2128,7 @@
                 <a:spcPts val="1500"/>
               </a:spcAft>
               <a:buChar char="•"/>
+              <a:defRPr/>
             </a:lvl3pPr>
             <a:lvl4pPr marL="1428750" indent="-285750">
               <a:lnSpc>
@@ -2057,6 +2141,7 @@
                 <a:spcPts val="1500"/>
               </a:spcAft>
               <a:buChar char="•"/>
+              <a:defRPr/>
             </a:lvl4pPr>
             <a:lvl5pPr marL="1809750" indent="-285750">
               <a:lnSpc>
@@ -2069,6 +2154,7 @@
                 <a:spcPts val="1500"/>
               </a:spcAft>
               <a:buChar char="•"/>
+              <a:defRPr/>
             </a:lvl5pPr>
             <a:lvl6pPr marL="2190750" indent="-285750">
               <a:lnSpc>
@@ -2081,6 +2167,7 @@
                 <a:spcPts val="1500"/>
               </a:spcAft>
               <a:buChar char="•"/>
+              <a:defRPr/>
             </a:lvl6pPr>
             <a:lvl7pPr marL="2571750" indent="-285750">
               <a:lnSpc>
@@ -2093,6 +2180,7 @@
                 <a:spcPts val="1500"/>
               </a:spcAft>
               <a:buChar char="•"/>
+              <a:defRPr/>
             </a:lvl7pPr>
             <a:lvl8pPr marL="2952750" indent="-285750">
               <a:lnSpc>
@@ -2105,6 +2193,7 @@
                 <a:spcPts val="1500"/>
               </a:spcAft>
               <a:buChar char="•"/>
+              <a:defRPr/>
             </a:lvl8pPr>
             <a:lvl9pPr marL="3333750" indent="-285750">
               <a:lnSpc>
@@ -2117,6 +2206,7 @@
                 <a:spcPts val="1500"/>
               </a:spcAft>
               <a:buChar char="•"/>
+              <a:defRPr/>
             </a:lvl9pPr>
           </a:lstStyle>
           <a:p xmlns:a="http://schemas.openxmlformats.org/drawingml/2006/main"/>
@@ -2165,12 +2255,12 @@
   </p:cSld>
   <p:clrMap bg1="lt1" tx1="dk1" bg2="lt2" tx2="dk2" accent1="accent1" accent2="accent2" accent3="accent3" accent4="accent4" accent5="accent5" accent6="accent6" hlink="hlink" folHlink="folHlink"/>
   <p:sldLayoutIdLst>
-    <p:sldLayoutId xmlns:r="http://schemas.openxmlformats.org/officeDocument/2006/relationships" id="2147483649" r:id="R50b5f947f2c842e9"/>
-    <p:sldLayoutId xmlns:r="http://schemas.openxmlformats.org/officeDocument/2006/relationships" id="2147483650" r:id="Recaea85fb4634be0"/>
-    <p:sldLayoutId xmlns:r="http://schemas.openxmlformats.org/officeDocument/2006/relationships" id="2147483651" r:id="R042b705b4cea48f7"/>
-    <p:sldLayoutId xmlns:r="http://schemas.openxmlformats.org/officeDocument/2006/relationships" id="2147483652" r:id="R176322f242b04fe4"/>
-    <p:sldLayoutId xmlns:r="http://schemas.openxmlformats.org/officeDocument/2006/relationships" id="2147483653" r:id="Racdbffba660942bd"/>
-    <p:sldLayoutId xmlns:r="http://schemas.openxmlformats.org/officeDocument/2006/relationships" id="2147483654" r:id="R728a490f16214227"/>
+    <p:sldLayoutId xmlns:r="http://schemas.openxmlformats.org/officeDocument/2006/relationships" id="2147483649" r:id="Rade7907cb53d447a"/>
+    <p:sldLayoutId xmlns:r="http://schemas.openxmlformats.org/officeDocument/2006/relationships" id="2147483650" r:id="R35cbb0e6ff804248"/>
+    <p:sldLayoutId xmlns:r="http://schemas.openxmlformats.org/officeDocument/2006/relationships" id="2147483651" r:id="R0a6f4a4214674c39"/>
+    <p:sldLayoutId xmlns:r="http://schemas.openxmlformats.org/officeDocument/2006/relationships" id="2147483652" r:id="Re2d49f29ad2d4f66"/>
+    <p:sldLayoutId xmlns:r="http://schemas.openxmlformats.org/officeDocument/2006/relationships" id="2147483653" r:id="Re08e5e9736f24058"/>
+    <p:sldLayoutId xmlns:r="http://schemas.openxmlformats.org/officeDocument/2006/relationships" id="2147483654" r:id="R672c070cd0b34cae"/>
   </p:sldLayoutIdLst>
   <p:txStyles>
     <p:titleStyle>
@@ -2759,6 +2849,7 @@
           </a:lstStyle>
           <a:p xmlns:a="http://schemas.openxmlformats.org/drawingml/2006/main">
             <a:pPr>
+              <a:buNone/>
               <a:defRPr sz="3600" b="1">
                 <a:solidFill>
                   <a:srgbClr val="203864"/>
@@ -2825,6 +2916,7 @@
           </a:lstStyle>
           <a:p xmlns:a="http://schemas.openxmlformats.org/drawingml/2006/main">
             <a:pPr>
+              <a:buNone/>
               <a:defRPr sz="2400" b="0">
                 <a:solidFill>
                   <a:srgbClr val="142337"/>
@@ -2891,6 +2983,7 @@
           </a:lstStyle>
           <a:p xmlns:a="http://schemas.openxmlformats.org/drawingml/2006/main">
             <a:pPr>
+              <a:buNone/>
               <a:defRPr sz="2400" b="1">
                 <a:solidFill>
                   <a:srgbClr val="203864"/>
@@ -2957,6 +3050,7 @@
           </a:lstStyle>
           <a:p xmlns:a="http://schemas.openxmlformats.org/drawingml/2006/main">
             <a:pPr>
+              <a:buNone/>
               <a:defRPr sz="2175" b="0">
                 <a:solidFill>
                   <a:srgbClr val="142337"/>
@@ -3023,6 +3117,7 @@
           </a:lstStyle>
           <a:p xmlns:a="http://schemas.openxmlformats.org/drawingml/2006/main">
             <a:pPr>
+              <a:buNone/>
               <a:defRPr sz="2400" b="1">
                 <a:solidFill>
                   <a:srgbClr val="203864"/>
@@ -3089,6 +3184,7 @@
           </a:lstStyle>
           <a:p xmlns:a="http://schemas.openxmlformats.org/drawingml/2006/main">
             <a:pPr>
+              <a:buNone/>
               <a:defRPr sz="2175" b="0">
                 <a:solidFill>
                   <a:srgbClr val="142337"/>
@@ -3155,6 +3251,7 @@
           </a:lstStyle>
           <a:p xmlns:a="http://schemas.openxmlformats.org/drawingml/2006/main">
             <a:pPr>
+              <a:buNone/>
               <a:defRPr sz="2400" b="1">
                 <a:solidFill>
                   <a:srgbClr val="9C2531"/>
@@ -3221,6 +3318,7 @@
           </a:lstStyle>
           <a:p xmlns:a="http://schemas.openxmlformats.org/drawingml/2006/main">
             <a:pPr>
+              <a:buNone/>
               <a:defRPr sz="2175" b="0">
                 <a:solidFill>
                   <a:srgbClr val="142337"/>
@@ -3287,6 +3385,7 @@
           </a:lstStyle>
           <a:p xmlns:a="http://schemas.openxmlformats.org/drawingml/2006/main">
             <a:pPr>
+              <a:buNone/>
               <a:defRPr sz="2400" b="1">
                 <a:solidFill>
                   <a:srgbClr val="203864"/>
@@ -3353,6 +3452,7 @@
           </a:lstStyle>
           <a:p xmlns:a="http://schemas.openxmlformats.org/drawingml/2006/main">
             <a:pPr>
+              <a:buNone/>
               <a:defRPr sz="2175" b="0">
                 <a:solidFill>
                   <a:srgbClr val="142337"/>
@@ -3419,6 +3519,7 @@
           </a:lstStyle>
           <a:p xmlns:a="http://schemas.openxmlformats.org/drawingml/2006/main">
             <a:pPr>
+              <a:buNone/>
               <a:defRPr sz="1575" b="0">
                 <a:solidFill>
                   <a:srgbClr val="58677A"/>

</xml_diff>